<commit_message>
fix: preserve editable connector arrowheads
Co-authored-by: run luo <RainBowLuoCS@users.noreply.github.com>
</commit_message>
<xml_diff>
--- a/deliverables/vcm_presentation/VCM_论文汇报_可编辑版.pptx
+++ b/deliverables/vcm_presentation/VCM_论文汇报_可编辑版.pptx
@@ -4394,6 +4394,7 @@
             <a:solidFill>
               <a:srgbClr val="FFFFFF"/>
             </a:solidFill>
+            <a:tailEnd type="triangle"/>
           </a:ln>
         </p:spPr>
         <p:style>
@@ -4429,6 +4430,7 @@
             <a:solidFill>
               <a:srgbClr val="FFFFFF"/>
             </a:solidFill>
+            <a:tailEnd type="triangle"/>
           </a:ln>
         </p:spPr>
         <p:style>
@@ -5470,6 +5472,7 @@
             <a:solidFill>
               <a:srgbClr val="2770B1"/>
             </a:solidFill>
+            <a:tailEnd type="triangle"/>
           </a:ln>
         </p:spPr>
         <p:style>
@@ -6045,6 +6048,7 @@
             <a:solidFill>
               <a:srgbClr val="2770B1"/>
             </a:solidFill>
+            <a:tailEnd type="triangle"/>
           </a:ln>
         </p:spPr>
         <p:style>
@@ -6195,6 +6199,7 @@
             <a:solidFill>
               <a:srgbClr val="009988"/>
             </a:solidFill>
+            <a:tailEnd type="triangle"/>
           </a:ln>
         </p:spPr>
         <p:style>
@@ -8197,6 +8202,7 @@
             <a:solidFill>
               <a:srgbClr val="2770B1"/>
             </a:solidFill>
+            <a:tailEnd type="triangle"/>
           </a:ln>
         </p:spPr>
         <p:style>
@@ -8347,6 +8353,7 @@
             <a:solidFill>
               <a:srgbClr val="009988"/>
             </a:solidFill>
+            <a:tailEnd type="triangle"/>
           </a:ln>
         </p:spPr>
         <p:style>
@@ -8533,6 +8540,7 @@
             <a:solidFill>
               <a:srgbClr val="5D6770"/>
             </a:solidFill>
+            <a:tailEnd type="triangle"/>
           </a:ln>
         </p:spPr>
         <p:style>
@@ -8648,6 +8656,7 @@
             <a:solidFill>
               <a:srgbClr val="5D6770"/>
             </a:solidFill>
+            <a:tailEnd type="triangle"/>
           </a:ln>
         </p:spPr>
         <p:style>
@@ -9719,6 +9728,7 @@
             <a:solidFill>
               <a:srgbClr val="009988"/>
             </a:solidFill>
+            <a:tailEnd type="triangle"/>
           </a:ln>
         </p:spPr>
         <p:style>
@@ -9949,6 +9959,7 @@
             <a:solidFill>
               <a:srgbClr val="07467C"/>
             </a:solidFill>
+            <a:tailEnd type="triangle"/>
           </a:ln>
         </p:spPr>
         <p:style>
@@ -9984,6 +9995,7 @@
             <a:solidFill>
               <a:srgbClr val="07467C"/>
             </a:solidFill>
+            <a:tailEnd type="triangle"/>
           </a:ln>
         </p:spPr>
         <p:style>
@@ -18149,6 +18161,7 @@
             <a:solidFill>
               <a:srgbClr val="CE2636"/>
             </a:solidFill>
+            <a:tailEnd type="triangle"/>
           </a:ln>
         </p:spPr>
         <p:style>
@@ -18300,6 +18313,7 @@
             <a:solidFill>
               <a:srgbClr val="CE2636"/>
             </a:solidFill>
+            <a:tailEnd type="triangle"/>
           </a:ln>
         </p:spPr>
         <p:style>
@@ -23477,6 +23491,7 @@
             <a:solidFill>
               <a:srgbClr val="2770B1"/>
             </a:solidFill>
+            <a:tailEnd type="triangle"/>
           </a:ln>
         </p:spPr>
         <p:style>
@@ -27803,6 +27818,7 @@
             <a:solidFill>
               <a:srgbClr val="2770B1"/>
             </a:solidFill>
+            <a:tailEnd type="triangle"/>
           </a:ln>
         </p:spPr>
         <p:style>
@@ -27838,6 +27854,7 @@
             <a:solidFill>
               <a:srgbClr val="EE7733"/>
             </a:solidFill>
+            <a:tailEnd type="triangle"/>
           </a:ln>
         </p:spPr>
         <p:style>
@@ -27990,6 +28007,7 @@
             <a:solidFill>
               <a:srgbClr val="009988"/>
             </a:solidFill>
+            <a:tailEnd type="triangle"/>
           </a:ln>
         </p:spPr>
         <p:style>
@@ -33390,6 +33408,7 @@
             <a:solidFill>
               <a:srgbClr val="2770B1"/>
             </a:solidFill>
+            <a:tailEnd type="triangle"/>
           </a:ln>
         </p:spPr>
         <p:style>
@@ -33655,6 +33674,7 @@
             <a:solidFill>
               <a:srgbClr val="EE7733"/>
             </a:solidFill>
+            <a:tailEnd type="triangle"/>
           </a:ln>
         </p:spPr>
         <p:style>
@@ -34336,6 +34356,7 @@
             <a:solidFill>
               <a:srgbClr val="5D6770"/>
             </a:solidFill>
+            <a:tailEnd type="triangle"/>
           </a:ln>
         </p:spPr>
         <p:style>
@@ -34761,6 +34782,7 @@
             <a:solidFill>
               <a:srgbClr val="5D6770"/>
             </a:solidFill>
+            <a:tailEnd type="triangle"/>
           </a:ln>
         </p:spPr>
         <p:style>
@@ -34981,6 +35003,7 @@
             <a:solidFill>
               <a:srgbClr val="5D6770"/>
             </a:solidFill>
+            <a:tailEnd type="triangle"/>
           </a:ln>
         </p:spPr>
         <p:style>
@@ -36923,6 +36946,7 @@
             <a:solidFill>
               <a:srgbClr val="EE7733"/>
             </a:solidFill>
+            <a:tailEnd type="triangle"/>
           </a:ln>
         </p:spPr>
         <p:style>
@@ -36958,6 +36982,7 @@
             <a:solidFill>
               <a:srgbClr val="2770B1"/>
             </a:solidFill>
+            <a:tailEnd type="triangle"/>
           </a:ln>
         </p:spPr>
         <p:style>
@@ -36993,6 +37018,7 @@
             <a:solidFill>
               <a:srgbClr val="EE7733"/>
             </a:solidFill>
+            <a:tailEnd type="triangle"/>
           </a:ln>
         </p:spPr>
         <p:style>
@@ -37028,6 +37054,7 @@
             <a:solidFill>
               <a:srgbClr val="2770B1"/>
             </a:solidFill>
+            <a:tailEnd type="triangle"/>
           </a:ln>
         </p:spPr>
         <p:style>
@@ -37063,6 +37090,7 @@
             <a:solidFill>
               <a:srgbClr val="EE7733"/>
             </a:solidFill>
+            <a:tailEnd type="triangle"/>
           </a:ln>
         </p:spPr>
         <p:style>
@@ -37098,6 +37126,7 @@
             <a:solidFill>
               <a:srgbClr val="2770B1"/>
             </a:solidFill>
+            <a:tailEnd type="triangle"/>
           </a:ln>
         </p:spPr>
         <p:style>

</xml_diff>